<commit_message>
fix: Day 1 deck's word-cloud slide shows only the prompt
"What do you remember?" now works with Menti or a flipchart without
editing; the notes say how to run it either way (house rule for tool
slides). Blueprint wording updated to match.

Co-Authored-By: Claude Opus 5.5 <noreply@anthropic.com>
</commit_message>
<xml_diff>
--- a/site/public/slides/tts-day1-death-by-powerpoint.pptx
+++ b/site/public/slides/tts-day1-death-by-powerpoint.pptx
@@ -3162,73 +3162,47 @@
           <a:lstStyle/>
           <a:p>
             <a:r>
-              <a:rPr dirty="0"/>
               <a:t>TIMING</a:t>
             </a:r>
           </a:p>
           <a:p>
             <a:r>
-              <a:rPr dirty="0"/>
               <a:t>  0:10–0:14 (4 min)</a:t>
             </a:r>
           </a:p>
           <a:p>
             <a:r>
-              <a:rPr dirty="0"/>
               <a:t>SAY</a:t>
             </a:r>
           </a:p>
           <a:p>
             <a:r>
-              <a:rPr dirty="0"/>
-              <a:t>  One or two words each.</a:t>
-            </a:r>
-          </a:p>
-          <a:p>
-            <a:r>
-              <a:rPr dirty="0"/>
-              <a:t>  Read the cloud out. Let the laughter happen.</a:t>
-            </a:r>
-          </a:p>
-          <a:p>
-            <a:r>
-              <a:rPr dirty="0"/>
+              <a:t>  One or two words each. Read the answers out; let the laughter happen.</a:t>
+            </a:r>
+          </a:p>
+          <a:p>
+            <a:r>
+              <a:t>HOW TO RUN</a:t>
+            </a:r>
+          </a:p>
+          <a:p>
+            <a:r>
+              <a:t>  Menti word cloud: show Menti alongside this slide, or paste your own QR code and joining code onto it.</a:t>
+            </a:r>
+          </a:p>
+          <a:p>
+            <a:r>
+              <a:t>  No Menti, or no wifi? Shout-outs onto the whiteboard or a flipchart. The slide works either way.</a:t>
+            </a:r>
+          </a:p>
+          <a:p>
+            <a:r>
               <a:t>WHY</a:t>
             </a:r>
           </a:p>
           <a:p>
             <a:r>
-              <a:rPr dirty="0"/>
-              <a:t>  A 30-second retrieval test of an overloaded slide: feel the problem before the theory.</a:t>
-            </a:r>
-          </a:p>
-          <a:p>
-            <a:r>
-              <a:rPr dirty="0"/>
-              <a:t>FALLBACK</a:t>
-            </a:r>
-          </a:p>
-          <a:p>
-            <a:r>
-              <a:rPr dirty="0"/>
-              <a:t>  Shout-outs onto the whiteboard.</a:t>
-            </a:r>
-          </a:p>
-          <a:p>
-            <a:r>
-              <a:rPr dirty="0"/>
-              <a:t>IF SHORT</a:t>
-            </a:r>
-          </a:p>
-          <a:p>
-            <a:r>
-              <a:rPr dirty="0"/>
-              <a:t>  Skip Menti; go straight to shout-outs.</a:t>
-            </a:r>
-          </a:p>
-          <a:p>
-            <a:r>
-              <a:t>SETUP: create your own Menti word cloud and paste its QR code and joining code here.</a:t>
+              <a:t>  A 30-second retrieval test of an overloaded slide: they feel the problem before the theory.</a:t>
             </a:r>
           </a:p>
         </p:txBody>
@@ -14851,161 +14825,6 @@
           <a:chExt cx="0" cy="0"/>
         </a:xfrm>
       </p:grpSpPr>
-      <p:sp>
-        <p:nvSpPr>
-          <p:cNvPr id="2" name="TextBox 1"/>
-          <p:cNvSpPr txBox="1"/>
-          <p:nvPr/>
-        </p:nvSpPr>
-        <p:spPr>
-          <a:xfrm>
-            <a:off x="548640" y="411480"/>
-            <a:ext cx="10515600" cy="914400"/>
-          </a:xfrm>
-          <a:prstGeom prst="rect">
-            <a:avLst/>
-          </a:prstGeom>
-          <a:noFill/>
-        </p:spPr>
-        <p:txBody>
-          <a:bodyPr wrap="square" lIns="73152" rIns="73152" anchor="t">
-            <a:spAutoFit/>
-          </a:bodyPr>
-          <a:lstStyle/>
-          <a:p>
-            <a:pPr algn="l"/>
-            <a:r>
-              <a:rPr sz="4400" b="1">
-                <a:solidFill>
-                  <a:srgbClr val="4C4F69"/>
-                </a:solidFill>
-                <a:latin typeface="Georgia"/>
-              </a:rPr>
-              <a:t>What do you remember?</a:t>
-            </a:r>
-          </a:p>
-        </p:txBody>
-      </p:sp>
-      <p:sp>
-        <p:nvSpPr>
-          <p:cNvPr id="4" name="TextBox 3"/>
-          <p:cNvSpPr txBox="1"/>
-          <p:nvPr/>
-        </p:nvSpPr>
-        <p:spPr>
-          <a:xfrm>
-            <a:off x="7254239" y="2606040"/>
-            <a:ext cx="3713873" cy="769441"/>
-          </a:xfrm>
-          <a:prstGeom prst="rect">
-            <a:avLst/>
-          </a:prstGeom>
-          <a:noFill/>
-        </p:spPr>
-        <p:txBody>
-          <a:bodyPr wrap="square" lIns="73152" rIns="73152" anchor="t">
-            <a:spAutoFit/>
-          </a:bodyPr>
-          <a:lstStyle/>
-          <a:p>
-            <a:pPr algn="l"/>
-            <a:r>
-              <a:rPr sz="4400" b="1" dirty="0" err="1">
-                <a:solidFill>
-                  <a:srgbClr val="036D97"/>
-                </a:solidFill>
-                <a:latin typeface="Aptos"/>
-              </a:rPr>
-              <a:t>menti.com</a:t>
-            </a:r>
-            <a:endParaRPr sz="4400" b="1" dirty="0">
-              <a:solidFill>
-                <a:srgbClr val="036D97"/>
-              </a:solidFill>
-              <a:latin typeface="Aptos"/>
-            </a:endParaRPr>
-          </a:p>
-        </p:txBody>
-      </p:sp>
-      <p:sp>
-        <p:nvSpPr>
-          <p:cNvPr id="5" name="TextBox 4"/>
-          <p:cNvSpPr txBox="1"/>
-          <p:nvPr/>
-        </p:nvSpPr>
-        <p:spPr>
-          <a:xfrm>
-            <a:off x="7254239" y="3520440"/>
-            <a:ext cx="3713873" cy="646331"/>
-          </a:xfrm>
-          <a:prstGeom prst="rect">
-            <a:avLst/>
-          </a:prstGeom>
-          <a:noFill/>
-        </p:spPr>
-        <p:txBody>
-          <a:bodyPr wrap="square" lIns="73152" rIns="73152" anchor="t">
-            <a:spAutoFit/>
-          </a:bodyPr>
-          <a:lstStyle/>
-          <a:p>
-            <a:pPr algn="l"/>
-            <a:r>
-              <a:rPr sz="3600" b="0" dirty="0">
-                <a:solidFill>
-                  <a:srgbClr val="4C4F69"/>
-                </a:solidFill>
-                <a:latin typeface="Aptos"/>
-              </a:rPr>
-              <a:t>code </a:t>
-            </a:r>
-            <a:r>
-              <a:rPr lang="en-GB" sz="3600" b="1" dirty="0">
-                <a:solidFill>
-                  <a:srgbClr val="036D97"/>
-                </a:solidFill>
-                <a:latin typeface="Aptos"/>
-              </a:rPr>
-              <a:t>____ ____</a:t>
-            </a:r>
-          </a:p>
-        </p:txBody>
-      </p:sp>
-      <p:sp>
-        <p:nvSpPr>
-          <p:cNvPr id="6" name="TextBox 5"/>
-          <p:cNvSpPr txBox="1"/>
-          <p:nvPr/>
-        </p:nvSpPr>
-        <p:spPr>
-          <a:xfrm>
-            <a:off x="7254239" y="4434840"/>
-            <a:ext cx="3713873" cy="523220"/>
-          </a:xfrm>
-          <a:prstGeom prst="rect">
-            <a:avLst/>
-          </a:prstGeom>
-          <a:noFill/>
-        </p:spPr>
-        <p:txBody>
-          <a:bodyPr wrap="square" lIns="73152" rIns="73152" anchor="t">
-            <a:spAutoFit/>
-          </a:bodyPr>
-          <a:lstStyle/>
-          <a:p>
-            <a:pPr algn="l"/>
-            <a:r>
-              <a:rPr sz="2800" b="0">
-                <a:solidFill>
-                  <a:srgbClr val="4C4F69"/>
-                </a:solidFill>
-                <a:latin typeface="Aptos"/>
-              </a:rPr>
-              <a:t>One or two words each</a:t>
-            </a:r>
-          </a:p>
-        </p:txBody>
-      </p:sp>
       <p:pic>
         <p:nvPicPr>
           <p:cNvPr id="7" name="Picture 6"/>
@@ -15038,53 +14857,88 @@
       </p:pic>
       <p:sp>
         <p:nvSpPr>
-          <p:cNvPr id="8" name="Rounded Rectangle 7"/>
-          <p:cNvSpPr/>
+          <p:cNvPr id="8" name="TextBox 7"/>
+          <p:cNvSpPr txBox="1"/>
           <p:nvPr/>
         </p:nvSpPr>
         <p:spPr>
           <a:xfrm>
-            <a:off x="1589180" y="1699846"/>
-            <a:ext cx="4506820" cy="4506820"/>
+            <a:off x="914400" y="2011680"/>
+            <a:ext cx="10363200" cy="1463040"/>
           </a:xfrm>
-          <a:prstGeom prst="roundRect">
+          <a:prstGeom prst="rect">
             <a:avLst/>
           </a:prstGeom>
-          <a:solidFill>
-            <a:srgbClr val="EFF1F5"/>
-          </a:solidFill>
-          <a:ln w="25400">
-            <a:solidFill>
-              <a:srgbClr val="036D97"/>
-            </a:solidFill>
-            <a:prstDash val="dash"/>
-          </a:ln>
+          <a:noFill/>
         </p:spPr>
-        <p:style>
-          <a:lnRef idx="1">
-            <a:schemeClr val="accent1"/>
-          </a:lnRef>
-          <a:fillRef idx="3">
-            <a:schemeClr val="accent1"/>
-          </a:fillRef>
-          <a:effectRef idx="2">
-            <a:schemeClr val="accent1"/>
-          </a:effectRef>
-          <a:fontRef idx="minor">
-            <a:schemeClr val="lt1"/>
-          </a:fontRef>
-        </p:style>
-        <p:txBody>
-          <a:bodyPr rtlCol="0" anchor="ctr"/>
+        <p:txBody>
+          <a:bodyPr wrap="square" anchor="ctr">
+            <a:spAutoFit/>
+          </a:bodyPr>
           <a:lstStyle/>
           <a:p>
-            <a:r>
-              <a:rPr sz="2400">
-                <a:solidFill>
-                  <a:srgbClr val="036D97"/>
-                </a:solidFill>
-              </a:rPr>
-              <a:t>Paste your Menti QR code here</a:t>
+            <a:pPr algn="ctr"/>
+            <a:r>
+              <a:rPr sz="5400" b="1">
+                <a:solidFill>
+                  <a:srgbClr val="4C4F69"/>
+                </a:solidFill>
+                <a:latin typeface="Georgia"/>
+              </a:rPr>
+              <a:t>What do you </a:t>
+            </a:r>
+            <a:r>
+              <a:rPr sz="5400" b="1">
+                <a:solidFill>
+                  <a:srgbClr val="B24101"/>
+                </a:solidFill>
+                <a:latin typeface="Georgia"/>
+              </a:rPr>
+              <a:t>remember</a:t>
+            </a:r>
+            <a:r>
+              <a:rPr sz="5400" b="1">
+                <a:solidFill>
+                  <a:srgbClr val="4C4F69"/>
+                </a:solidFill>
+                <a:latin typeface="Georgia"/>
+              </a:rPr>
+              <a:t>?</a:t>
+            </a:r>
+          </a:p>
+        </p:txBody>
+      </p:sp>
+      <p:sp>
+        <p:nvSpPr>
+          <p:cNvPr id="9" name="TextBox 8"/>
+          <p:cNvSpPr txBox="1"/>
+          <p:nvPr/>
+        </p:nvSpPr>
+        <p:spPr>
+          <a:xfrm>
+            <a:off x="914400" y="3657600"/>
+            <a:ext cx="10363200" cy="822960"/>
+          </a:xfrm>
+          <a:prstGeom prst="rect">
+            <a:avLst/>
+          </a:prstGeom>
+          <a:noFill/>
+        </p:spPr>
+        <p:txBody>
+          <a:bodyPr wrap="square" anchor="ctr">
+            <a:spAutoFit/>
+          </a:bodyPr>
+          <a:lstStyle/>
+          <a:p>
+            <a:pPr algn="ctr"/>
+            <a:r>
+              <a:rPr sz="3200" b="0">
+                <a:solidFill>
+                  <a:srgbClr val="4C4F69"/>
+                </a:solidFill>
+                <a:latin typeface="Aptos"/>
+              </a:rPr>
+              <a:t>One or two words each</a:t>
             </a:r>
           </a:p>
         </p:txBody>

</xml_diff>

<commit_message>
feat: Day 1 goes paper-first, with the slide kit; downloads stack as a list
Both redesign rounds now start from the printed falls slide kit
(credits page included). PowerPoint becomes the laptop route for
people who are comfortable with it. Consecutive download cards stack
vertically; download + Open live stays side by side.

Co-Authored-By: Claude Opus 5.5 <noreply@anthropic.com>
</commit_message>
<xml_diff>
--- a/site/public/slides/tts-day1-death-by-powerpoint.pptx
+++ b/site/public/slides/tts-day1-death-by-powerpoint.pptx
@@ -758,81 +758,67 @@
           <a:lstStyle/>
           <a:p>
             <a:r>
-              <a:rPr dirty="0"/>
               <a:t>TIMING</a:t>
             </a:r>
           </a:p>
           <a:p>
             <a:r>
-              <a:rPr dirty="0"/>
               <a:t>  0:22–0:39 (15 min + 2 min swap)</a:t>
             </a:r>
           </a:p>
           <a:p>
             <a:r>
-              <a:rPr dirty="0"/>
               <a:t>SAY</a:t>
             </a:r>
           </a:p>
           <a:p>
             <a:r>
-              <a:rPr dirty="0"/>
-              <a:t>  One slide (yours, one from the pack, or one you find on the intranet), not the whole deck.</a:t>
-            </a:r>
-          </a:p>
-          <a:p>
-            <a:r>
-              <a:rPr dirty="0"/>
-              <a:t>  Then swap with a </a:t>
-            </a:r>
-            <a:r>
-              <a:rPr dirty="0" err="1"/>
-              <a:t>neighbour</a:t>
-            </a:r>
-            <a:r>
-              <a:rPr dirty="0"/>
-              <a:t> for 2 minutes: what did they cut?</a:t>
-            </a:r>
-          </a:p>
-          <a:p>
-            <a:r>
-              <a:rPr dirty="0"/>
-              <a:t>FALLBACK</a:t>
-            </a:r>
-          </a:p>
-          <a:p>
-            <a:r>
-              <a:rPr dirty="0"/>
-              <a:t>  No slide → the bad-slide pack. No device → redesign on paper (a storyboard counts).</a:t>
-            </a:r>
-          </a:p>
-          <a:p>
-            <a:r>
-              <a:rPr dirty="0"/>
-              <a:t>WATCH FOR</a:t>
-            </a:r>
-          </a:p>
-          <a:p>
-            <a:r>
-              <a:rPr dirty="0"/>
-              <a:t>  'My Trust template won't let me' → acknowledge; park it for 'Show us'.</a:t>
-            </a:r>
-          </a:p>
-          <a:p>
-            <a:r>
-              <a:rPr dirty="0"/>
+              <a:t>  Build one slide from the kit that helps a nurse do ONE thing before leaving the bedside. Choose your pieces, cut the noise, image + voice. Anything needed but not for the learner's eyes goes in the speaker-notes strip.</a:t>
+            </a:r>
+          </a:p>
+          <a:p>
+            <a:r>
+              <a:t>  Comfortable on a laptop? Do it in PowerPoint on a slide of your own instead. Same rules.</a:t>
+            </a:r>
+          </a:p>
+          <a:p>
+            <a:r>
+              <a:t>  Then 2 minutes swapping with a neighbour: what did they discard?</a:t>
+            </a:r>
+          </a:p>
+          <a:p>
+            <a:r>
+              <a:t>FACILITATOR</a:t>
+            </a:r>
+          </a:p>
+          <a:p>
+            <a:r>
+              <a:t>  Hand out the falls slide kit (pre-cut in envelopes saves 5 minutes): the frame, the pieces, scissors or Blu Tack.</a:t>
+            </a:r>
+          </a:p>
+          <a:p>
+            <a:r>
+              <a:t>  Laptop route only: show once on screen: select slides (Shift / Ctrl / Cmd-click), Duplicate slide, Undo, Designer off.</a:t>
+            </a:r>
+          </a:p>
+          <a:p>
+            <a:r>
+              <a:t>WHY</a:t>
+            </a:r>
+          </a:p>
+          <a:p>
+            <a:r>
+              <a:t>  Paper takes the computer out of the way: the decisions (what stays, what goes, how big, where) are the skill. Picking and arranging given parts is a completion task, which suits novices (Sweller). The discard pile is extraneous load you can point at.</a:t>
+            </a:r>
+          </a:p>
+          <a:p>
+            <a:r>
               <a:t>IF SHORT</a:t>
             </a:r>
           </a:p>
           <a:p>
             <a:r>
-              <a:rPr dirty="0"/>
-              <a:t>  Cut the swap, not the redesign.</a:t>
-            </a:r>
-          </a:p>
-          <a:p>
-            <a:r>
-              <a:t>FACILITATOR: expect basic PowerPoint gaps. Show once, on screen: Shift-click / Ctrl-click (Cmd-click on Mac) to select several slides, right-click → Duplicate slide, Ctrl/Cmd+Z to undo, and switch off Designer suggestions. Then go round the room.</a:t>
+              <a:t>  Cut the swap, not the build.</a:t>
             </a:r>
           </a:p>
         </p:txBody>
@@ -1307,38 +1293,52 @@
           <a:lstStyle/>
           <a:p>
             <a:r>
-              <a:rPr dirty="0"/>
               <a:t>TIMING</a:t>
             </a:r>
           </a:p>
           <a:p>
             <a:r>
-              <a:rPr dirty="0"/>
               <a:t>  0:44–0:59 (15 min)</a:t>
             </a:r>
           </a:p>
           <a:p>
             <a:r>
-              <a:rPr dirty="0"/>
               <a:t>SAY</a:t>
             </a:r>
           </a:p>
           <a:p>
             <a:r>
-              <a:rPr dirty="0"/>
-              <a:t>  Same slide. Review → Check Accessibility.</a:t>
-            </a:r>
-          </a:p>
-          <a:p>
-            <a:r>
-              <a:rPr dirty="0"/>
+              <a:t>  Same slide, accessibility pass. Swap pieces for size and contrast; no meaning by colour alone.</a:t>
+            </a:r>
+          </a:p>
+          <a:p>
+            <a:r>
+              <a:t>  Then HOLD IT UP across the room: can the back row read it?</a:t>
+            </a:r>
+          </a:p>
+          <a:p>
+            <a:r>
+              <a:t>  Laptop route: Review → Check Accessibility.</a:t>
+            </a:r>
+          </a:p>
+          <a:p>
+            <a:r>
+              <a:t>WHY</a:t>
+            </a:r>
+          </a:p>
+          <a:p>
+            <a:r>
+              <a:t>  The readability test becomes physical: they feel 24pt rather than being told it.</a:t>
+            </a:r>
+          </a:p>
+          <a:p>
+            <a:r>
               <a:t>FALLBACK</a:t>
             </a:r>
           </a:p>
           <a:p>
             <a:r>
-              <a:rPr dirty="0"/>
-              <a:t>  Paper: write size and contrast choices onto the storyboard.</a:t>
+              <a:t>  No laptops needed: this round is designed for paper.</a:t>
             </a:r>
           </a:p>
         </p:txBody>
@@ -8057,7 +8057,7 @@
                 </a:solidFill>
                 <a:latin typeface="Aptos"/>
               </a:rPr>
-              <a:t>Pick one slide</a:t>
+              <a:t>Pick your pieces</a:t>
             </a:r>
           </a:p>
         </p:txBody>
@@ -8275,7 +8275,7 @@
                 </a:solidFill>
                 <a:latin typeface="Aptos"/>
               </a:rPr>
-              <a:t>then 2 min swap with a </a:t>
+              <a:t>on paper (laptop if you're comfy) · </a:t>
             </a:r>
             <a:r>
               <a:rPr sz="3000" b="0" dirty="0" err="1">
@@ -8284,7 +8284,7 @@
                 </a:solidFill>
                 <a:latin typeface="Aptos"/>
               </a:rPr>
-              <a:t>neighbour</a:t>
+              <a:t>then swap</a:t>
             </a:r>
             <a:endParaRPr sz="3000" b="0" dirty="0">
               <a:solidFill>
@@ -10062,7 +10062,7 @@
                 </a:solidFill>
                 <a:latin typeface="Aptos"/>
               </a:rPr>
-              <a:t>Use</a:t>
+              <a:t>Hold it up!</a:t>
             </a:r>
             <a:r>
               <a:rPr sz="2800" b="1" dirty="0">
@@ -10071,7 +10071,7 @@
                 </a:solidFill>
                 <a:latin typeface="Aptos"/>
               </a:rPr>
-              <a:t> </a:t>
+              <a:t/>
             </a:r>
             <a:r>
               <a:rPr lang="en-GB" sz="2800" b="1" dirty="0">
@@ -10080,7 +10080,7 @@
                 </a:solidFill>
                 <a:latin typeface="Aptos"/>
               </a:rPr>
-              <a:t>accessibility </a:t>
+              <a:t/>
             </a:r>
             <a:r>
               <a:rPr sz="2800" b="1" dirty="0">
@@ -10089,7 +10089,7 @@
                 </a:solidFill>
                 <a:latin typeface="Aptos"/>
               </a:rPr>
-              <a:t>checker</a:t>
+              <a:t/>
             </a:r>
           </a:p>
         </p:txBody>
@@ -10151,7 +10151,7 @@
                 </a:solidFill>
                 <a:latin typeface="Aptos"/>
               </a:rPr>
-              <a:t>  same slide, accessibility pass</a:t>
+              <a:t>  same slide · laptop: run the accessibility checker</a:t>
             </a:r>
           </a:p>
         </p:txBody>

</xml_diff>